<commit_message>
If player took damage, search for the closest zombie and we know if he is behind now!
My moving is based on the vision of the player, if the zombie is behind the player wont see it - so see if the player is taking damage, and with that, we know if there is someone behind now this works!!
Tried 2 methods one in the student perceptor but that didnt work well so changed to update stats and that works
</commit_message>
<xml_diff>
--- a/GPP_ZombieAI_LastNameFirstName_2DAEXX.pptx
+++ b/GPP_ZombieAI_LastNameFirstName_2DAEXX.pptx
@@ -405,7 +405,7 @@
           <a:p>
             <a:fld id="{82085877-2B37-48E7-8B6D-4D4ED486130A}" type="datetimeFigureOut">
               <a:rPr lang="en-BE" smtClean="0"/>
-              <a:t>11/28/2023</a:t>
+              <a:t>05/18/2026</a:t>
             </a:fld>
             <a:endParaRPr lang="en-BE"/>
           </a:p>
@@ -459,7 +459,7 @@
           <a:p>
             <a:fld id="{F15161DE-E191-4798-91BE-355EA90292A5}" type="slidenum">
               <a:rPr lang="en-BE" smtClean="0"/>
-              <a:t>‹#›</a:t>
+              <a:t>‹nº›</a:t>
             </a:fld>
             <a:endParaRPr lang="en-BE"/>
           </a:p>
@@ -605,7 +605,7 @@
           <a:p>
             <a:fld id="{82085877-2B37-48E7-8B6D-4D4ED486130A}" type="datetimeFigureOut">
               <a:rPr lang="en-BE" smtClean="0"/>
-              <a:t>11/28/2023</a:t>
+              <a:t>05/18/2026</a:t>
             </a:fld>
             <a:endParaRPr lang="en-BE"/>
           </a:p>
@@ -659,7 +659,7 @@
           <a:p>
             <a:fld id="{F15161DE-E191-4798-91BE-355EA90292A5}" type="slidenum">
               <a:rPr lang="en-BE" smtClean="0"/>
-              <a:t>‹#›</a:t>
+              <a:t>‹nº›</a:t>
             </a:fld>
             <a:endParaRPr lang="en-BE"/>
           </a:p>
@@ -815,7 +815,7 @@
           <a:p>
             <a:fld id="{82085877-2B37-48E7-8B6D-4D4ED486130A}" type="datetimeFigureOut">
               <a:rPr lang="en-BE" smtClean="0"/>
-              <a:t>11/28/2023</a:t>
+              <a:t>05/18/2026</a:t>
             </a:fld>
             <a:endParaRPr lang="en-BE"/>
           </a:p>
@@ -869,7 +869,7 @@
           <a:p>
             <a:fld id="{F15161DE-E191-4798-91BE-355EA90292A5}" type="slidenum">
               <a:rPr lang="en-BE" smtClean="0"/>
-              <a:t>‹#›</a:t>
+              <a:t>‹nº›</a:t>
             </a:fld>
             <a:endParaRPr lang="en-BE"/>
           </a:p>
@@ -1015,7 +1015,7 @@
           <a:p>
             <a:fld id="{82085877-2B37-48E7-8B6D-4D4ED486130A}" type="datetimeFigureOut">
               <a:rPr lang="en-BE" smtClean="0"/>
-              <a:t>11/28/2023</a:t>
+              <a:t>05/18/2026</a:t>
             </a:fld>
             <a:endParaRPr lang="en-BE"/>
           </a:p>
@@ -1069,7 +1069,7 @@
           <a:p>
             <a:fld id="{F15161DE-E191-4798-91BE-355EA90292A5}" type="slidenum">
               <a:rPr lang="en-BE" smtClean="0"/>
-              <a:t>‹#›</a:t>
+              <a:t>‹nº›</a:t>
             </a:fld>
             <a:endParaRPr lang="en-BE"/>
           </a:p>
@@ -1291,7 +1291,7 @@
           <a:p>
             <a:fld id="{82085877-2B37-48E7-8B6D-4D4ED486130A}" type="datetimeFigureOut">
               <a:rPr lang="en-BE" smtClean="0"/>
-              <a:t>11/28/2023</a:t>
+              <a:t>05/18/2026</a:t>
             </a:fld>
             <a:endParaRPr lang="en-BE"/>
           </a:p>
@@ -1345,7 +1345,7 @@
           <a:p>
             <a:fld id="{F15161DE-E191-4798-91BE-355EA90292A5}" type="slidenum">
               <a:rPr lang="en-BE" smtClean="0"/>
-              <a:t>‹#›</a:t>
+              <a:t>‹nº›</a:t>
             </a:fld>
             <a:endParaRPr lang="en-BE"/>
           </a:p>
@@ -1559,7 +1559,7 @@
           <a:p>
             <a:fld id="{82085877-2B37-48E7-8B6D-4D4ED486130A}" type="datetimeFigureOut">
               <a:rPr lang="en-BE" smtClean="0"/>
-              <a:t>11/28/2023</a:t>
+              <a:t>05/18/2026</a:t>
             </a:fld>
             <a:endParaRPr lang="en-BE"/>
           </a:p>
@@ -1613,7 +1613,7 @@
           <a:p>
             <a:fld id="{F15161DE-E191-4798-91BE-355EA90292A5}" type="slidenum">
               <a:rPr lang="en-BE" smtClean="0"/>
-              <a:t>‹#›</a:t>
+              <a:t>‹nº›</a:t>
             </a:fld>
             <a:endParaRPr lang="en-BE"/>
           </a:p>
@@ -1974,7 +1974,7 @@
           <a:p>
             <a:fld id="{82085877-2B37-48E7-8B6D-4D4ED486130A}" type="datetimeFigureOut">
               <a:rPr lang="en-BE" smtClean="0"/>
-              <a:t>11/28/2023</a:t>
+              <a:t>05/18/2026</a:t>
             </a:fld>
             <a:endParaRPr lang="en-BE"/>
           </a:p>
@@ -2028,7 +2028,7 @@
           <a:p>
             <a:fld id="{F15161DE-E191-4798-91BE-355EA90292A5}" type="slidenum">
               <a:rPr lang="en-BE" smtClean="0"/>
-              <a:t>‹#›</a:t>
+              <a:t>‹nº›</a:t>
             </a:fld>
             <a:endParaRPr lang="en-BE"/>
           </a:p>
@@ -2116,7 +2116,7 @@
           <a:p>
             <a:fld id="{82085877-2B37-48E7-8B6D-4D4ED486130A}" type="datetimeFigureOut">
               <a:rPr lang="en-BE" smtClean="0"/>
-              <a:t>11/28/2023</a:t>
+              <a:t>05/18/2026</a:t>
             </a:fld>
             <a:endParaRPr lang="en-BE"/>
           </a:p>
@@ -2170,7 +2170,7 @@
           <a:p>
             <a:fld id="{F15161DE-E191-4798-91BE-355EA90292A5}" type="slidenum">
               <a:rPr lang="en-BE" smtClean="0"/>
-              <a:t>‹#›</a:t>
+              <a:t>‹nº›</a:t>
             </a:fld>
             <a:endParaRPr lang="en-BE"/>
           </a:p>
@@ -2229,7 +2229,7 @@
           <a:p>
             <a:fld id="{82085877-2B37-48E7-8B6D-4D4ED486130A}" type="datetimeFigureOut">
               <a:rPr lang="en-BE" smtClean="0"/>
-              <a:t>11/28/2023</a:t>
+              <a:t>05/18/2026</a:t>
             </a:fld>
             <a:endParaRPr lang="en-BE"/>
           </a:p>
@@ -2283,7 +2283,7 @@
           <a:p>
             <a:fld id="{F15161DE-E191-4798-91BE-355EA90292A5}" type="slidenum">
               <a:rPr lang="en-BE" smtClean="0"/>
-              <a:t>‹#›</a:t>
+              <a:t>‹nº›</a:t>
             </a:fld>
             <a:endParaRPr lang="en-BE"/>
           </a:p>
@@ -2542,7 +2542,7 @@
           <a:p>
             <a:fld id="{82085877-2B37-48E7-8B6D-4D4ED486130A}" type="datetimeFigureOut">
               <a:rPr lang="en-BE" smtClean="0"/>
-              <a:t>11/28/2023</a:t>
+              <a:t>05/18/2026</a:t>
             </a:fld>
             <a:endParaRPr lang="en-BE"/>
           </a:p>
@@ -2596,7 +2596,7 @@
           <a:p>
             <a:fld id="{F15161DE-E191-4798-91BE-355EA90292A5}" type="slidenum">
               <a:rPr lang="en-BE" smtClean="0"/>
-              <a:t>‹#›</a:t>
+              <a:t>‹nº›</a:t>
             </a:fld>
             <a:endParaRPr lang="en-BE"/>
           </a:p>
@@ -2831,7 +2831,7 @@
           <a:p>
             <a:fld id="{82085877-2B37-48E7-8B6D-4D4ED486130A}" type="datetimeFigureOut">
               <a:rPr lang="en-BE" smtClean="0"/>
-              <a:t>11/28/2023</a:t>
+              <a:t>05/18/2026</a:t>
             </a:fld>
             <a:endParaRPr lang="en-BE"/>
           </a:p>
@@ -2885,7 +2885,7 @@
           <a:p>
             <a:fld id="{F15161DE-E191-4798-91BE-355EA90292A5}" type="slidenum">
               <a:rPr lang="en-BE" smtClean="0"/>
-              <a:t>‹#›</a:t>
+              <a:t>‹nº›</a:t>
             </a:fld>
             <a:endParaRPr lang="en-BE"/>
           </a:p>
@@ -3074,7 +3074,7 @@
           <a:p>
             <a:fld id="{82085877-2B37-48E7-8B6D-4D4ED486130A}" type="datetimeFigureOut">
               <a:rPr lang="en-BE" smtClean="0"/>
-              <a:t>11/28/2023</a:t>
+              <a:t>05/18/2026</a:t>
             </a:fld>
             <a:endParaRPr lang="en-BE"/>
           </a:p>
@@ -3164,7 +3164,7 @@
           <a:p>
             <a:fld id="{F15161DE-E191-4798-91BE-355EA90292A5}" type="slidenum">
               <a:rPr lang="en-BE" smtClean="0"/>
-              <a:t>‹#›</a:t>
+              <a:t>‹nº›</a:t>
             </a:fld>
             <a:endParaRPr lang="en-BE"/>
           </a:p>
@@ -3676,6 +3676,29 @@
               </a:rPr>
               <a:t>Tip: use miro.com!</a:t>
             </a:r>
+          </a:p>
+          <a:p>
+            <a:pPr lvl="1"/>
+            <a:r>
+              <a:rPr lang="en-US" i="1" dirty="0">
+                <a:solidFill>
+                  <a:schemeClr val="bg1">
+                    <a:lumMod val="75000"/>
+                  </a:schemeClr>
+                </a:solidFill>
+              </a:rPr>
+              <a:t>Make it pretty the </a:t>
+            </a:r>
+            <a:r>
+              <a:rPr lang="en-US" i="1" dirty="0" err="1">
+                <a:solidFill>
+                  <a:schemeClr val="bg1">
+                    <a:lumMod val="75000"/>
+                  </a:schemeClr>
+                </a:solidFill>
+              </a:rPr>
+              <a:t>bt</a:t>
+            </a:r>
             <a:endParaRPr lang="en-BE" i="1" dirty="0">
               <a:solidFill>
                 <a:schemeClr val="bg1">
@@ -3767,7 +3790,7 @@
           <a:lstStyle/>
           <a:p>
             <a:r>
-              <a:rPr lang="en-US" i="1">
+              <a:rPr lang="en-US" i="1" dirty="0">
                 <a:solidFill>
                   <a:schemeClr val="bg1">
                     <a:lumMod val="75000"/>
@@ -3776,7 +3799,7 @@
               </a:rPr>
               <a:t>How does your agent deal with enemies (aiming, shooting, item usage, avoidance, hiding, usage of sprint, …)?</a:t>
             </a:r>
-            <a:endParaRPr lang="en-BE" i="1">
+            <a:endParaRPr lang="en-BE" i="1" dirty="0">
               <a:solidFill>
                 <a:schemeClr val="bg1">
                   <a:lumMod val="75000"/>
@@ -3786,7 +3809,7 @@
           </a:p>
           <a:p>
             <a:r>
-              <a:rPr lang="en-US" i="1">
+              <a:rPr lang="en-US" i="1" dirty="0">
                 <a:solidFill>
                   <a:schemeClr val="bg1">
                     <a:lumMod val="75000"/>
@@ -3795,7 +3818,7 @@
               </a:rPr>
               <a:t>USE IMAGES/GIFS</a:t>
             </a:r>
-            <a:endParaRPr lang="en-BE"/>
+            <a:endParaRPr lang="en-BE" dirty="0"/>
           </a:p>
         </p:txBody>
       </p:sp>
@@ -3887,18 +3910,8 @@
                   </a:schemeClr>
                 </a:solidFill>
               </a:rPr>
-              <a:t>How does your agent manage the inventory (inventory organization, item usage, picking up and remembering items,…)? </a:t>
-            </a:r>
-            <a:endParaRPr lang="en-BE" i="1" dirty="0">
-              <a:solidFill>
-                <a:schemeClr val="bg1">
-                  <a:lumMod val="75000"/>
-                </a:schemeClr>
-              </a:solidFill>
-            </a:endParaRPr>
-          </a:p>
-          <a:p>
-            <a:endParaRPr lang="en-BE" dirty="0"/>
+              <a:t>How does your agent manage the inventory (inventory organization, item usage, picking up and remembering items,…)?</a:t>
+            </a:r>
           </a:p>
         </p:txBody>
       </p:sp>
@@ -3992,6 +4005,27 @@
               </a:rPr>
               <a:t>How many steering behaviors does it use? Does it use blended steering?</a:t>
             </a:r>
+          </a:p>
+          <a:p>
+            <a:endParaRPr lang="en-US" i="1" dirty="0">
+              <a:solidFill>
+                <a:schemeClr val="bg1">
+                  <a:lumMod val="75000"/>
+                </a:schemeClr>
+              </a:solidFill>
+            </a:endParaRPr>
+          </a:p>
+          <a:p>
+            <a:r>
+              <a:rPr lang="en-US" i="1" dirty="0">
+                <a:solidFill>
+                  <a:schemeClr val="bg1">
+                    <a:lumMod val="75000"/>
+                  </a:schemeClr>
+                </a:solidFill>
+              </a:rPr>
+              <a:t>Use blended steering even if it works better without</a:t>
+            </a:r>
             <a:endParaRPr lang="en-BE" i="1" dirty="0">
               <a:solidFill>
                 <a:schemeClr val="bg1">
@@ -4207,7 +4241,7 @@
               <a:buNone/>
             </a:pPr>
             <a:r>
-              <a:rPr lang="en-US">
+              <a:rPr lang="en-US" dirty="0">
                 <a:solidFill>
                   <a:schemeClr val="bg1">
                     <a:lumMod val="75000"/>
@@ -4216,7 +4250,54 @@
               </a:rPr>
               <a:t>Screen shot or list of highest scores</a:t>
             </a:r>
-            <a:endParaRPr lang="en-BE">
+          </a:p>
+          <a:p>
+            <a:pPr marL="0" indent="0">
+              <a:buNone/>
+            </a:pPr>
+            <a:endParaRPr lang="en-US" dirty="0">
+              <a:solidFill>
+                <a:schemeClr val="bg1">
+                  <a:lumMod val="75000"/>
+                </a:schemeClr>
+              </a:solidFill>
+            </a:endParaRPr>
+          </a:p>
+          <a:p>
+            <a:pPr marL="0" indent="0">
+              <a:buNone/>
+            </a:pPr>
+            <a:r>
+              <a:rPr lang="en-US" dirty="0">
+                <a:solidFill>
+                  <a:schemeClr val="bg1">
+                    <a:lumMod val="75000"/>
+                  </a:schemeClr>
+                </a:solidFill>
+              </a:rPr>
+              <a:t>Ignore this title add whatever I want here! </a:t>
+            </a:r>
+            <a:r>
+              <a:rPr lang="en-US" dirty="0" err="1">
+                <a:solidFill>
+                  <a:schemeClr val="bg1">
+                    <a:lumMod val="75000"/>
+                  </a:schemeClr>
+                </a:solidFill>
+              </a:rPr>
+              <a:t>Img</a:t>
+            </a:r>
+            <a:r>
+              <a:rPr lang="en-US" dirty="0">
+                <a:solidFill>
+                  <a:schemeClr val="bg1">
+                    <a:lumMod val="75000"/>
+                  </a:schemeClr>
+                </a:solidFill>
+              </a:rPr>
+              <a:t> or thank you or name</a:t>
+            </a:r>
+            <a:endParaRPr lang="en-BE" dirty="0">
               <a:solidFill>
                 <a:schemeClr val="bg1">
                   <a:lumMod val="75000"/>
@@ -4544,6 +4625,21 @@
 </file>
 
 <file path=customXml/item2.xml><?xml version="1.0" encoding="utf-8"?>
+<p:properties xmlns:p="http://schemas.microsoft.com/office/2006/metadata/properties" xmlns:xsi="http://www.w3.org/2001/XMLSchema-instance" xmlns:pc="http://schemas.microsoft.com/office/infopath/2007/PartnerControls">
+  <documentManagement>
+    <IconOverlay xmlns="http://schemas.microsoft.com/sharepoint/v4" xsi:nil="true"/>
+    <TaxCatchAll xmlns="128482ec-0431-40d5-ab26-89ea2a4f3ccd" xsi:nil="true"/>
+    <m99485b88215436a82099f8287cba0b0 xmlns="128482ec-0431-40d5-ab26-89ea2a4f3ccd">
+      <Terms xmlns="http://schemas.microsoft.com/office/infopath/2007/PartnerControls"/>
+    </m99485b88215436a82099f8287cba0b0>
+    <lcf76f155ced4ddcb4097134ff3c332f xmlns="60eb0cf4-ae2a-4762-800a-cb593b869ecb">
+      <Terms xmlns="http://schemas.microsoft.com/office/infopath/2007/PartnerControls"/>
+    </lcf76f155ced4ddcb4097134ff3c332f>
+  </documentManagement>
+</p:properties>
+</file>
+
+<file path=customXml/item3.xml><?xml version="1.0" encoding="utf-8"?>
 <ct:contentTypeSchema xmlns:ct="http://schemas.microsoft.com/office/2006/metadata/contentType" xmlns:ma="http://schemas.microsoft.com/office/2006/metadata/properties/metaAttributes" ct:_="" ma:_="" ma:contentTypeName="Document" ma:contentTypeID="0x010100723942CCEB3A674D8F1F6472CCEFB38E" ma:contentTypeVersion="11" ma:contentTypeDescription="Create a new document." ma:contentTypeScope="" ma:versionID="e4de40d148e029d40e3aaddc8bf68a5e">
   <xsd:schema xmlns:xsd="http://www.w3.org/2001/XMLSchema" xmlns:xs="http://www.w3.org/2001/XMLSchema" xmlns:p="http://schemas.microsoft.com/office/2006/metadata/properties" xmlns:ns2="128482ec-0431-40d5-ab26-89ea2a4f3ccd" xmlns:ns3="60eb0cf4-ae2a-4762-800a-cb593b869ecb" xmlns:ns4="http://schemas.microsoft.com/sharepoint/v4" xmlns:ns5="a2e691a9-fcfc-4d85-a390-1894fe98bd9e" targetNamespace="http://schemas.microsoft.com/office/2006/metadata/properties" ma:root="true" ma:fieldsID="fce8e8bd091658f3fe51b22d57dec109" ns2:_="" ns3:_="" ns4:_="" ns5:_="">
     <xsd:import namespace="128482ec-0431-40d5-ab26-89ea2a4f3ccd"/>
@@ -4816,21 +4912,6 @@
 </ct:contentTypeSchema>
 </file>
 
-<file path=customXml/item3.xml><?xml version="1.0" encoding="utf-8"?>
-<p:properties xmlns:p="http://schemas.microsoft.com/office/2006/metadata/properties" xmlns:xsi="http://www.w3.org/2001/XMLSchema-instance" xmlns:pc="http://schemas.microsoft.com/office/infopath/2007/PartnerControls">
-  <documentManagement>
-    <IconOverlay xmlns="http://schemas.microsoft.com/sharepoint/v4" xsi:nil="true"/>
-    <TaxCatchAll xmlns="128482ec-0431-40d5-ab26-89ea2a4f3ccd" xsi:nil="true"/>
-    <m99485b88215436a82099f8287cba0b0 xmlns="128482ec-0431-40d5-ab26-89ea2a4f3ccd">
-      <Terms xmlns="http://schemas.microsoft.com/office/infopath/2007/PartnerControls"/>
-    </m99485b88215436a82099f8287cba0b0>
-    <lcf76f155ced4ddcb4097134ff3c332f xmlns="60eb0cf4-ae2a-4762-800a-cb593b869ecb">
-      <Terms xmlns="http://schemas.microsoft.com/office/infopath/2007/PartnerControls"/>
-    </lcf76f155ced4ddcb4097134ff3c332f>
-  </documentManagement>
-</p:properties>
-</file>
-
 <file path=customXml/itemProps1.xml><?xml version="1.0" encoding="utf-8"?>
 <ds:datastoreItem xmlns:ds="http://schemas.openxmlformats.org/officeDocument/2006/customXml" ds:itemID="{AF8EC6D1-CB19-4400-AD0A-0C75CD884AEA}">
   <ds:schemaRefs>
@@ -4840,6 +4921,18 @@
 </file>
 
 <file path=customXml/itemProps2.xml><?xml version="1.0" encoding="utf-8"?>
+<ds:datastoreItem xmlns:ds="http://schemas.openxmlformats.org/officeDocument/2006/customXml" ds:itemID="{B743389A-7EE0-4951-8919-E91DD69E3687}">
+  <ds:schemaRefs>
+    <ds:schemaRef ds:uri="128482ec-0431-40d5-ab26-89ea2a4f3ccd"/>
+    <ds:schemaRef ds:uri="http://schemas.microsoft.com/office/2006/metadata/properties"/>
+    <ds:schemaRef ds:uri="http://schemas.microsoft.com/office/infopath/2007/PartnerControls"/>
+    <ds:schemaRef ds:uri="http://schemas.microsoft.com/sharepoint/v4"/>
+    <ds:schemaRef ds:uri="60eb0cf4-ae2a-4762-800a-cb593b869ecb"/>
+  </ds:schemaRefs>
+</ds:datastoreItem>
+</file>
+
+<file path=customXml/itemProps3.xml><?xml version="1.0" encoding="utf-8"?>
 <ds:datastoreItem xmlns:ds="http://schemas.openxmlformats.org/officeDocument/2006/customXml" ds:itemID="{D7B8C5DE-3345-4025-A942-C5AA68E55545}">
   <ds:schemaRefs>
     <ds:schemaRef ds:uri="http://schemas.microsoft.com/office/2006/metadata/contentType"/>
@@ -4858,16 +4951,4 @@
     <ds:schemaRef ds:uri="http://schemas.microsoft.com/internal/obd"/>
   </ds:schemaRefs>
 </ds:datastoreItem>
-</file>
-
-<file path=customXml/itemProps3.xml><?xml version="1.0" encoding="utf-8"?>
-<ds:datastoreItem xmlns:ds="http://schemas.openxmlformats.org/officeDocument/2006/customXml" ds:itemID="{B743389A-7EE0-4951-8919-E91DD69E3687}">
-  <ds:schemaRefs>
-    <ds:schemaRef ds:uri="128482ec-0431-40d5-ab26-89ea2a4f3ccd"/>
-    <ds:schemaRef ds:uri="http://schemas.microsoft.com/office/2006/metadata/properties"/>
-    <ds:schemaRef ds:uri="http://schemas.microsoft.com/office/infopath/2007/PartnerControls"/>
-    <ds:schemaRef ds:uri="http://schemas.microsoft.com/sharepoint/v4"/>
-    <ds:schemaRef ds:uri="60eb0cf4-ae2a-4762-800a-cb593b869ecb"/>
-  </ds:schemaRefs>
-</ds:datastoreItem>
 </file>
</xml_diff>